<commit_message>
feat: probability calibration, 2-model arena compare, heatmap caption
- Probability calibration (calibrate_probabilities.py): per-category Platt/isotonic
  picked by held-out CV Brier; macro Brier 0.176->0.034, ECE 0.316->0.033. Saved
  version-independent and applied live (server returns calibrated_probability);
  exposed via /api/evaluation and the Evaluation page. Regression tests added.
- Arena: side-by-side two-model comparison (pin runs to A/B, metric deltas) and a
  calibrated-probability readout + heatmap caption in the prediction modal.
- Re-ran gen_tables.py / gen_figures.py; documented calibration in RELAZIONE_v2
  (§8.9) and regenerated the PDF + 19-slide deck. Commit the built frontend dist.

Co-Authored-By: Claude Opus 4.8 <noreply@anthropic.com>
</commit_message>
<xml_diff>
--- a/relazione/PRESENTAZIONE_v2.pptx
+++ b/relazione/PRESENTAZIONE_v2.pptx
@@ -5194,8 +5194,8 @@
         </p:blipFill>
         <p:spPr>
           <a:xfrm>
-            <a:off x="1139647" y="1463040"/>
-            <a:ext cx="9909657" cy="4389120"/>
+            <a:off x="1129039" y="1463040"/>
+            <a:ext cx="9930872" cy="4389120"/>
           </a:xfrm>
           <a:prstGeom prst="rect">
             <a:avLst/>
@@ -6520,7 +6520,7 @@
                 </a:solidFill>
                 <a:latin typeface="Segoe UI"/>
               </a:rPr>
-              <a:t>Soglia onesta, non oracle: </a:t>
+              <a:t>Calibrazione onesta (soglia + probabilita'): </a:t>
             </a:r>
             <a:r>
               <a:rPr sz="1500" b="0" i="0">
@@ -6529,7 +6529,7 @@
                 </a:solidFill>
                 <a:latin typeface="Segoe UI"/>
               </a:rPr>
-              <a:t>la best-F1 guarda le etichette del test; con cross-validation l'accuratezza dispiegabile e' 0.954 vs 0.968 oracle (gap +1.4pp): l'operating point e' stabile</a:t>
+              <a:t>best-F1 e' un oracle -&gt; accuratezza held-out 0.954 vs 0.968; lo score grezzo non e' una probabilita' (ECE 0.32) -&gt; calibrato Platt/isotonica ECE 0.03 (held-out)</a:t>
             </a:r>
           </a:p>
           <a:p>
@@ -10198,8 +10198,8 @@
         </p:blipFill>
         <p:spPr>
           <a:xfrm>
-            <a:off x="548640" y="2011113"/>
-            <a:ext cx="11091672" cy="3338692"/>
+            <a:off x="548640" y="2012048"/>
+            <a:ext cx="11091672" cy="3336822"/>
           </a:xfrm>
           <a:prstGeom prst="rect">
             <a:avLst/>

</xml_diff>